<commit_message>
Noyabrsk slide: restore chips for employed, population and gross value added, drop budget chip
Co-Authored-By: Claude Sonnet 5.5 <noreply@anthropic.com>
Claude-Session: https://claude.ai/code/session_01PfagTkBBfn3ShTm5bX9M45
</commit_message>
<xml_diff>
--- a/slide_noyabrsk_vs_rossiya.pptx
+++ b/slide_noyabrsk_vs_rossiya.pptx
@@ -430,7 +430,7 @@
           <a:lstStyle/>
           <a:p>
             <a:r>
-              <a:t>Слайд перестроен по образцу слайда про Севастополь. Существующее положение Ноябрьска сравнивается со средними по России, которые использованы на слайде про Севастополь (структура занятости, структура ВРП и производительность по видам деятельности). Данные Ноябрьска взяты из прежнего слайда (значения существующего положения), производительность переведена из млн руб. в тыс. руб. Ось ВГП растянута до 70 процентов из-за доли добычи (64,3 процента). Средняя производительность (8 240 тыс. руб.) и ВГП на душу (4 410 тыс. руб.) рассчитаны как 453,5 млрд руб. на 55,0 тыс. занятых и на 102,9 тыс. жителей. Прогноз к 2035 году и приросты показателей со слайда убраны. Среднероссийская производительность по видам деятельности из слайда про Севастополь даёт взвешенное среднее около 1170 тыс. руб. при заявленных 1690 тыс. руб., расхождение стоит проверить.</a:t>
+              <a:t>Слайд перестроен по образцу слайда про Севастополь. Существующее положение Ноябрьска сравнивается со средними по России, которые использованы на слайде про Севастополь (структура занятости, структура ВРП и производительность по видам деятельности). Данные Ноябрьска взяты из прежнего слайда (значения существующего положения), производительность переведена из млн руб. в тыс. руб. Ось ВГП растянута до 70 процентов из-за доли добычи (64,3 процента). Шарики с численностью занятых, населения и валовой добавленной стоимостью оставлены с прежнего слайда (значения существующего положения), шарик с доходами бюджета убран. Средняя производительность (8 240 тыс. руб.) и ВГП на душу (4 410 тыс. руб.) рассчитаны как 453,5 млрд руб. на 55,0 тыс. занятых и на 102,9 тыс. жителей. Прогноз к 2035 году и приросты показателей со слайда убраны. Среднероссийская производительность по видам деятельности из слайда про Севастополь даёт взвешенное среднее около 1170 тыс. руб. при заявленных 1690 тыс. руб., расхождение стоит проверить.</a:t>
             </a:r>
           </a:p>
         </p:txBody>
@@ -13999,301 +13999,16 @@
       </p:sp>
       <p:sp>
         <p:nvSpPr>
-          <p:cNvPr id="550" name="Показатель"/>
-          <p:cNvSpPr txBox="1"/>
+          <p:cNvPr id="550" name="Шарик"/>
+          <p:cNvSpPr/>
           <p:nvPr/>
         </p:nvSpPr>
         <p:spPr>
           <a:xfrm>
             <a:off x="14401800" y="2011680"/>
-            <a:ext cx="3538728" cy="822960"/>
-          </a:xfrm>
-          <a:prstGeom prst="rect">
-            <a:avLst/>
-          </a:prstGeom>
-          <a:noFill/>
-        </p:spPr>
-        <p:txBody>
-          <a:bodyPr wrap="square" anchor="ctr" lIns="0" rIns="0" tIns="0" bIns="0">
-            <a:spAutoFit/>
-          </a:bodyPr>
-          <a:lstStyle/>
-          <a:p>
-            <a:pPr algn="l"/>
-            <a:r>
-              <a:rPr sz="4800" b="1">
-                <a:solidFill>
-                  <a:srgbClr val="B07D00"/>
-                </a:solidFill>
-                <a:latin typeface="Circe Bold"/>
-              </a:rPr>
-              <a:t>55</a:t>
-            </a:r>
-            <a:r>
-              <a:rPr sz="1800" b="1">
-                <a:solidFill>
-                  <a:srgbClr val="B07D00"/>
-                </a:solidFill>
-                <a:latin typeface="Circe Bold"/>
-              </a:rPr>
-              <a:t> тыс. чел.</a:t>
-            </a:r>
-          </a:p>
-        </p:txBody>
-      </p:sp>
-      <p:sp>
-        <p:nvSpPr>
-          <p:cNvPr id="551" name="Пояснение"/>
-          <p:cNvSpPr txBox="1"/>
-          <p:nvPr/>
-        </p:nvSpPr>
-        <p:spPr>
-          <a:xfrm>
-            <a:off x="14401800" y="2880360"/>
-            <a:ext cx="3538728" cy="1280160"/>
-          </a:xfrm>
-          <a:prstGeom prst="rect">
-            <a:avLst/>
-          </a:prstGeom>
-          <a:noFill/>
-        </p:spPr>
-        <p:txBody>
-          <a:bodyPr wrap="square" anchor="t" lIns="0" rIns="0" tIns="0" bIns="0">
-            <a:spAutoFit/>
-          </a:bodyPr>
-          <a:lstStyle/>
-          <a:p>
-            <a:pPr algn="l"/>
-            <a:r>
-              <a:rPr sz="1600" b="0">
-                <a:solidFill>
-                  <a:srgbClr val="062D3F"/>
-                </a:solidFill>
-                <a:latin typeface="Circe"/>
-              </a:rPr>
-              <a:t>Число занятых в экономике</a:t>
-            </a:r>
-          </a:p>
-          <a:p>
-            <a:pPr algn="l"/>
-            <a:r>
-              <a:rPr sz="1600" b="0">
-                <a:solidFill>
-                  <a:srgbClr val="062D3F"/>
-                </a:solidFill>
-                <a:latin typeface="Circe"/>
-              </a:rPr>
-              <a:t>Население 102,9 тыс. чел.</a:t>
-            </a:r>
-          </a:p>
-          <a:p>
-            <a:pPr algn="l"/>
-            <a:r>
-              <a:rPr sz="1600" b="0">
-                <a:solidFill>
-                  <a:srgbClr val="062D3F"/>
-                </a:solidFill>
-                <a:latin typeface="Circe"/>
-              </a:rPr>
-              <a:t>Доходы бюджета 46,0 млрд руб.</a:t>
-            </a:r>
-          </a:p>
-        </p:txBody>
-      </p:sp>
-      <p:sp>
-        <p:nvSpPr>
-          <p:cNvPr id="552" name="Показатель"/>
-          <p:cNvSpPr txBox="1"/>
-          <p:nvPr/>
-        </p:nvSpPr>
-        <p:spPr>
-          <a:xfrm>
-            <a:off x="14401800" y="4434840"/>
-            <a:ext cx="3538728" cy="822960"/>
-          </a:xfrm>
-          <a:prstGeom prst="rect">
-            <a:avLst/>
-          </a:prstGeom>
-          <a:noFill/>
-        </p:spPr>
-        <p:txBody>
-          <a:bodyPr wrap="square" anchor="ctr" lIns="0" rIns="0" tIns="0" bIns="0">
-            <a:spAutoFit/>
-          </a:bodyPr>
-          <a:lstStyle/>
-          <a:p>
-            <a:pPr algn="l"/>
-            <a:r>
-              <a:rPr sz="4800" b="1">
-                <a:solidFill>
-                  <a:srgbClr val="B07D00"/>
-                </a:solidFill>
-                <a:latin typeface="Circe Bold"/>
-              </a:rPr>
-              <a:t>8 240</a:t>
-            </a:r>
-            <a:r>
-              <a:rPr sz="1800" b="1">
-                <a:solidFill>
-                  <a:srgbClr val="B07D00"/>
-                </a:solidFill>
-                <a:latin typeface="Circe Bold"/>
-              </a:rPr>
-              <a:t> тыс. руб.</a:t>
-            </a:r>
-          </a:p>
-        </p:txBody>
-      </p:sp>
-      <p:sp>
-        <p:nvSpPr>
-          <p:cNvPr id="553" name="Пояснение"/>
-          <p:cNvSpPr txBox="1"/>
-          <p:nvPr/>
-        </p:nvSpPr>
-        <p:spPr>
-          <a:xfrm>
-            <a:off x="14401800" y="5303520"/>
-            <a:ext cx="3538728" cy="1280160"/>
-          </a:xfrm>
-          <a:prstGeom prst="rect">
-            <a:avLst/>
-          </a:prstGeom>
-          <a:noFill/>
-        </p:spPr>
-        <p:txBody>
-          <a:bodyPr wrap="square" anchor="t" lIns="0" rIns="0" tIns="0" bIns="0">
-            <a:spAutoFit/>
-          </a:bodyPr>
-          <a:lstStyle/>
-          <a:p>
-            <a:pPr algn="l"/>
-            <a:r>
-              <a:rPr sz="1600" b="0">
-                <a:solidFill>
-                  <a:srgbClr val="062D3F"/>
-                </a:solidFill>
-                <a:latin typeface="Circe"/>
-              </a:rPr>
-              <a:t>Средняя производительность труда на 1 работника</a:t>
-            </a:r>
-          </a:p>
-          <a:p>
-            <a:pPr algn="l"/>
-            <a:r>
-              <a:rPr sz="1600" b="0">
-                <a:solidFill>
-                  <a:srgbClr val="2F5D75"/>
-                </a:solidFill>
-                <a:latin typeface="Circe"/>
-              </a:rPr>
-              <a:t>РФ – 1690 тыс. руб.</a:t>
-            </a:r>
-          </a:p>
-        </p:txBody>
-      </p:sp>
-      <p:sp>
-        <p:nvSpPr>
-          <p:cNvPr id="554" name="Показатель"/>
-          <p:cNvSpPr txBox="1"/>
-          <p:nvPr/>
-        </p:nvSpPr>
-        <p:spPr>
-          <a:xfrm>
-            <a:off x="14401800" y="6766560"/>
-            <a:ext cx="3538728" cy="822960"/>
-          </a:xfrm>
-          <a:prstGeom prst="rect">
-            <a:avLst/>
-          </a:prstGeom>
-          <a:noFill/>
-        </p:spPr>
-        <p:txBody>
-          <a:bodyPr wrap="square" anchor="ctr" lIns="0" rIns="0" tIns="0" bIns="0">
-            <a:spAutoFit/>
-          </a:bodyPr>
-          <a:lstStyle/>
-          <a:p>
-            <a:pPr algn="l"/>
-            <a:r>
-              <a:rPr sz="4800" b="1">
-                <a:solidFill>
-                  <a:srgbClr val="B07D00"/>
-                </a:solidFill>
-                <a:latin typeface="Circe Bold"/>
-              </a:rPr>
-              <a:t>4 410</a:t>
-            </a:r>
-            <a:r>
-              <a:rPr sz="1800" b="1">
-                <a:solidFill>
-                  <a:srgbClr val="B07D00"/>
-                </a:solidFill>
-                <a:latin typeface="Circe Bold"/>
-              </a:rPr>
-              <a:t> тыс. руб.</a:t>
-            </a:r>
-          </a:p>
-        </p:txBody>
-      </p:sp>
-      <p:sp>
-        <p:nvSpPr>
-          <p:cNvPr id="555" name="Пояснение"/>
-          <p:cNvSpPr txBox="1"/>
-          <p:nvPr/>
-        </p:nvSpPr>
-        <p:spPr>
-          <a:xfrm>
-            <a:off x="14401800" y="7635240"/>
-            <a:ext cx="3538728" cy="1280160"/>
-          </a:xfrm>
-          <a:prstGeom prst="rect">
-            <a:avLst/>
-          </a:prstGeom>
-          <a:noFill/>
-        </p:spPr>
-        <p:txBody>
-          <a:bodyPr wrap="square" anchor="t" lIns="0" rIns="0" tIns="0" bIns="0">
-            <a:spAutoFit/>
-          </a:bodyPr>
-          <a:lstStyle/>
-          <a:p>
-            <a:pPr algn="l"/>
-            <a:r>
-              <a:rPr sz="1600" b="0">
-                <a:solidFill>
-                  <a:srgbClr val="062D3F"/>
-                </a:solidFill>
-                <a:latin typeface="Circe"/>
-              </a:rPr>
-              <a:t>ВГП на душу населения</a:t>
-            </a:r>
-          </a:p>
-          <a:p>
-            <a:pPr algn="l"/>
-            <a:r>
-              <a:rPr sz="1600" b="0">
-                <a:solidFill>
-                  <a:srgbClr val="2F5D75"/>
-                </a:solidFill>
-                <a:latin typeface="Circe"/>
-              </a:rPr>
-              <a:t>РФ – 824 тыс. руб.</a:t>
-            </a:r>
-          </a:p>
-        </p:txBody>
-      </p:sp>
-      <p:sp>
-        <p:nvSpPr>
-          <p:cNvPr id="556" name="Условный знак"/>
-          <p:cNvSpPr/>
-          <p:nvPr/>
-        </p:nvSpPr>
-        <p:spPr>
-          <a:xfrm>
-            <a:off x="14401800" y="8778240"/>
-            <a:ext cx="256032" cy="201168"/>
-          </a:xfrm>
-          <a:prstGeom prst="rect">
+            <a:ext cx="777240" cy="777240"/>
+          </a:xfrm>
+          <a:prstGeom prst="ellipse">
             <a:avLst/>
           </a:prstGeom>
           <a:solidFill>
@@ -14311,9 +14026,491 @@
           </a:p>
         </p:txBody>
       </p:sp>
-      <p:sp>
-        <p:nvSpPr>
-          <p:cNvPr id="557" name="Легенда"/>
+      <p:pic>
+        <p:nvPicPr>
+          <p:cNvPr id="551" name="Значок" descr="image.png"/>
+          <p:cNvPicPr>
+            <a:picLocks noChangeAspect="1"/>
+          </p:cNvPicPr>
+          <p:nvPr/>
+        </p:nvPicPr>
+        <p:blipFill>
+          <a:blip r:embed="rId2"/>
+          <a:stretch>
+            <a:fillRect/>
+          </a:stretch>
+        </p:blipFill>
+        <p:spPr>
+          <a:xfrm>
+            <a:off x="14575536" y="2185416"/>
+            <a:ext cx="429768" cy="429768"/>
+          </a:xfrm>
+          <a:prstGeom prst="rect">
+            <a:avLst/>
+          </a:prstGeom>
+        </p:spPr>
+      </p:pic>
+      <p:sp>
+        <p:nvSpPr>
+          <p:cNvPr id="552" name="Показатель"/>
+          <p:cNvSpPr txBox="1"/>
+          <p:nvPr/>
+        </p:nvSpPr>
+        <p:spPr>
+          <a:xfrm>
+            <a:off x="15361920" y="1965960"/>
+            <a:ext cx="2606040" cy="868680"/>
+          </a:xfrm>
+          <a:prstGeom prst="rect">
+            <a:avLst/>
+          </a:prstGeom>
+          <a:noFill/>
+        </p:spPr>
+        <p:txBody>
+          <a:bodyPr wrap="square" anchor="ctr" lIns="0" rIns="0" tIns="0" bIns="0">
+            <a:spAutoFit/>
+          </a:bodyPr>
+          <a:lstStyle/>
+          <a:p>
+            <a:pPr algn="l"/>
+            <a:r>
+              <a:rPr sz="2000" b="1">
+                <a:solidFill>
+                  <a:srgbClr val="062D3F"/>
+                </a:solidFill>
+                <a:latin typeface="Circe Bold"/>
+              </a:rPr>
+              <a:t>55 005 чел.</a:t>
+            </a:r>
+          </a:p>
+          <a:p>
+            <a:pPr algn="l"/>
+            <a:r>
+              <a:rPr sz="1400" b="1">
+                <a:solidFill>
+                  <a:srgbClr val="062D3F"/>
+                </a:solidFill>
+                <a:latin typeface="Circe Bold"/>
+              </a:rPr>
+              <a:t>Численность занятых</a:t>
+            </a:r>
+          </a:p>
+        </p:txBody>
+      </p:sp>
+      <p:sp>
+        <p:nvSpPr>
+          <p:cNvPr id="553" name="Шарик"/>
+          <p:cNvSpPr/>
+          <p:nvPr/>
+        </p:nvSpPr>
+        <p:spPr>
+          <a:xfrm>
+            <a:off x="14401800" y="3108960"/>
+            <a:ext cx="777240" cy="777240"/>
+          </a:xfrm>
+          <a:prstGeom prst="ellipse">
+            <a:avLst/>
+          </a:prstGeom>
+          <a:solidFill>
+            <a:srgbClr val="FFCC00"/>
+          </a:solidFill>
+          <a:ln>
+            <a:noFill/>
+          </a:ln>
+        </p:spPr>
+        <p:txBody>
+          <a:bodyPr rtlCol="0" anchor="ctr"/>
+          <a:lstStyle/>
+          <a:p>
+            <a:pPr algn="ctr"/>
+          </a:p>
+        </p:txBody>
+      </p:sp>
+      <p:pic>
+        <p:nvPicPr>
+          <p:cNvPr id="554" name="Значок" descr="image.png"/>
+          <p:cNvPicPr>
+            <a:picLocks noChangeAspect="1"/>
+          </p:cNvPicPr>
+          <p:nvPr/>
+        </p:nvPicPr>
+        <p:blipFill>
+          <a:blip r:embed="rId3"/>
+          <a:stretch>
+            <a:fillRect/>
+          </a:stretch>
+        </p:blipFill>
+        <p:spPr>
+          <a:xfrm>
+            <a:off x="14575536" y="3282696"/>
+            <a:ext cx="429768" cy="429768"/>
+          </a:xfrm>
+          <a:prstGeom prst="rect">
+            <a:avLst/>
+          </a:prstGeom>
+        </p:spPr>
+      </p:pic>
+      <p:sp>
+        <p:nvSpPr>
+          <p:cNvPr id="555" name="Показатель"/>
+          <p:cNvSpPr txBox="1"/>
+          <p:nvPr/>
+        </p:nvSpPr>
+        <p:spPr>
+          <a:xfrm>
+            <a:off x="15361920" y="3063240"/>
+            <a:ext cx="2606040" cy="868680"/>
+          </a:xfrm>
+          <a:prstGeom prst="rect">
+            <a:avLst/>
+          </a:prstGeom>
+          <a:noFill/>
+        </p:spPr>
+        <p:txBody>
+          <a:bodyPr wrap="square" anchor="ctr" lIns="0" rIns="0" tIns="0" bIns="0">
+            <a:spAutoFit/>
+          </a:bodyPr>
+          <a:lstStyle/>
+          <a:p>
+            <a:pPr algn="l"/>
+            <a:r>
+              <a:rPr sz="2000" b="1">
+                <a:solidFill>
+                  <a:srgbClr val="062D3F"/>
+                </a:solidFill>
+                <a:latin typeface="Circe Bold"/>
+              </a:rPr>
+              <a:t>102 938 чел.</a:t>
+            </a:r>
+          </a:p>
+          <a:p>
+            <a:pPr algn="l"/>
+            <a:r>
+              <a:rPr sz="1400" b="1">
+                <a:solidFill>
+                  <a:srgbClr val="062D3F"/>
+                </a:solidFill>
+                <a:latin typeface="Circe Bold"/>
+              </a:rPr>
+              <a:t>Численность населения</a:t>
+            </a:r>
+          </a:p>
+        </p:txBody>
+      </p:sp>
+      <p:sp>
+        <p:nvSpPr>
+          <p:cNvPr id="556" name="Шарик"/>
+          <p:cNvSpPr/>
+          <p:nvPr/>
+        </p:nvSpPr>
+        <p:spPr>
+          <a:xfrm>
+            <a:off x="14401800" y="4206240"/>
+            <a:ext cx="777240" cy="777240"/>
+          </a:xfrm>
+          <a:prstGeom prst="ellipse">
+            <a:avLst/>
+          </a:prstGeom>
+          <a:solidFill>
+            <a:srgbClr val="FFCC00"/>
+          </a:solidFill>
+          <a:ln>
+            <a:noFill/>
+          </a:ln>
+        </p:spPr>
+        <p:txBody>
+          <a:bodyPr rtlCol="0" anchor="ctr"/>
+          <a:lstStyle/>
+          <a:p>
+            <a:pPr algn="ctr"/>
+          </a:p>
+        </p:txBody>
+      </p:sp>
+      <p:pic>
+        <p:nvPicPr>
+          <p:cNvPr id="557" name="Значок" descr="image.png"/>
+          <p:cNvPicPr>
+            <a:picLocks noChangeAspect="1"/>
+          </p:cNvPicPr>
+          <p:nvPr/>
+        </p:nvPicPr>
+        <p:blipFill>
+          <a:blip r:embed="rId4"/>
+          <a:stretch>
+            <a:fillRect/>
+          </a:stretch>
+        </p:blipFill>
+        <p:spPr>
+          <a:xfrm>
+            <a:off x="14575536" y="4379976"/>
+            <a:ext cx="429768" cy="429768"/>
+          </a:xfrm>
+          <a:prstGeom prst="rect">
+            <a:avLst/>
+          </a:prstGeom>
+        </p:spPr>
+      </p:pic>
+      <p:sp>
+        <p:nvSpPr>
+          <p:cNvPr id="558" name="Показатель"/>
+          <p:cNvSpPr txBox="1"/>
+          <p:nvPr/>
+        </p:nvSpPr>
+        <p:spPr>
+          <a:xfrm>
+            <a:off x="15361920" y="4160520"/>
+            <a:ext cx="2606040" cy="868680"/>
+          </a:xfrm>
+          <a:prstGeom prst="rect">
+            <a:avLst/>
+          </a:prstGeom>
+          <a:noFill/>
+        </p:spPr>
+        <p:txBody>
+          <a:bodyPr wrap="square" anchor="ctr" lIns="0" rIns="0" tIns="0" bIns="0">
+            <a:spAutoFit/>
+          </a:bodyPr>
+          <a:lstStyle/>
+          <a:p>
+            <a:pPr algn="l"/>
+            <a:r>
+              <a:rPr sz="2000" b="1">
+                <a:solidFill>
+                  <a:srgbClr val="062D3F"/>
+                </a:solidFill>
+                <a:latin typeface="Circe Bold"/>
+              </a:rPr>
+              <a:t>453 млрд руб.</a:t>
+            </a:r>
+          </a:p>
+          <a:p>
+            <a:pPr algn="l"/>
+            <a:r>
+              <a:rPr sz="1400" b="1">
+                <a:solidFill>
+                  <a:srgbClr val="062D3F"/>
+                </a:solidFill>
+                <a:latin typeface="Circe Bold"/>
+              </a:rPr>
+              <a:t>Валовая добавленная стоимость</a:t>
+            </a:r>
+          </a:p>
+        </p:txBody>
+      </p:sp>
+      <p:sp>
+        <p:nvSpPr>
+          <p:cNvPr id="559" name="Показатель"/>
+          <p:cNvSpPr txBox="1"/>
+          <p:nvPr/>
+        </p:nvSpPr>
+        <p:spPr>
+          <a:xfrm>
+            <a:off x="14401800" y="5349240"/>
+            <a:ext cx="3538728" cy="731520"/>
+          </a:xfrm>
+          <a:prstGeom prst="rect">
+            <a:avLst/>
+          </a:prstGeom>
+          <a:noFill/>
+        </p:spPr>
+        <p:txBody>
+          <a:bodyPr wrap="square" anchor="ctr" lIns="0" rIns="0" tIns="0" bIns="0">
+            <a:spAutoFit/>
+          </a:bodyPr>
+          <a:lstStyle/>
+          <a:p>
+            <a:pPr algn="l"/>
+            <a:r>
+              <a:rPr sz="4400" b="1">
+                <a:solidFill>
+                  <a:srgbClr val="B07D00"/>
+                </a:solidFill>
+                <a:latin typeface="Circe Bold"/>
+              </a:rPr>
+              <a:t>8 240</a:t>
+            </a:r>
+            <a:r>
+              <a:rPr sz="1800" b="1">
+                <a:solidFill>
+                  <a:srgbClr val="B07D00"/>
+                </a:solidFill>
+                <a:latin typeface="Circe Bold"/>
+              </a:rPr>
+              <a:t> тыс. руб.</a:t>
+            </a:r>
+          </a:p>
+        </p:txBody>
+      </p:sp>
+      <p:sp>
+        <p:nvSpPr>
+          <p:cNvPr id="560" name="Пояснение"/>
+          <p:cNvSpPr txBox="1"/>
+          <p:nvPr/>
+        </p:nvSpPr>
+        <p:spPr>
+          <a:xfrm>
+            <a:off x="14401800" y="6126479"/>
+            <a:ext cx="3538728" cy="1097280"/>
+          </a:xfrm>
+          <a:prstGeom prst="rect">
+            <a:avLst/>
+          </a:prstGeom>
+          <a:noFill/>
+        </p:spPr>
+        <p:txBody>
+          <a:bodyPr wrap="square" anchor="t" lIns="0" rIns="0" tIns="0" bIns="0">
+            <a:spAutoFit/>
+          </a:bodyPr>
+          <a:lstStyle/>
+          <a:p>
+            <a:pPr algn="l"/>
+            <a:r>
+              <a:rPr sz="1600" b="0">
+                <a:solidFill>
+                  <a:srgbClr val="062D3F"/>
+                </a:solidFill>
+                <a:latin typeface="Circe"/>
+              </a:rPr>
+              <a:t>Средняя производительность труда на 1 работника</a:t>
+            </a:r>
+          </a:p>
+          <a:p>
+            <a:pPr algn="l"/>
+            <a:r>
+              <a:rPr sz="1600" b="0">
+                <a:solidFill>
+                  <a:srgbClr val="2F5D75"/>
+                </a:solidFill>
+                <a:latin typeface="Circe"/>
+              </a:rPr>
+              <a:t>РФ – 1690 тыс. руб.</a:t>
+            </a:r>
+          </a:p>
+        </p:txBody>
+      </p:sp>
+      <p:sp>
+        <p:nvSpPr>
+          <p:cNvPr id="561" name="Показатель"/>
+          <p:cNvSpPr txBox="1"/>
+          <p:nvPr/>
+        </p:nvSpPr>
+        <p:spPr>
+          <a:xfrm>
+            <a:off x="14401800" y="7223760"/>
+            <a:ext cx="3538728" cy="731520"/>
+          </a:xfrm>
+          <a:prstGeom prst="rect">
+            <a:avLst/>
+          </a:prstGeom>
+          <a:noFill/>
+        </p:spPr>
+        <p:txBody>
+          <a:bodyPr wrap="square" anchor="ctr" lIns="0" rIns="0" tIns="0" bIns="0">
+            <a:spAutoFit/>
+          </a:bodyPr>
+          <a:lstStyle/>
+          <a:p>
+            <a:pPr algn="l"/>
+            <a:r>
+              <a:rPr sz="4400" b="1">
+                <a:solidFill>
+                  <a:srgbClr val="B07D00"/>
+                </a:solidFill>
+                <a:latin typeface="Circe Bold"/>
+              </a:rPr>
+              <a:t>4 410</a:t>
+            </a:r>
+            <a:r>
+              <a:rPr sz="1800" b="1">
+                <a:solidFill>
+                  <a:srgbClr val="B07D00"/>
+                </a:solidFill>
+                <a:latin typeface="Circe Bold"/>
+              </a:rPr>
+              <a:t> тыс. руб.</a:t>
+            </a:r>
+          </a:p>
+        </p:txBody>
+      </p:sp>
+      <p:sp>
+        <p:nvSpPr>
+          <p:cNvPr id="562" name="Пояснение"/>
+          <p:cNvSpPr txBox="1"/>
+          <p:nvPr/>
+        </p:nvSpPr>
+        <p:spPr>
+          <a:xfrm>
+            <a:off x="14401800" y="8001000"/>
+            <a:ext cx="3538728" cy="1097280"/>
+          </a:xfrm>
+          <a:prstGeom prst="rect">
+            <a:avLst/>
+          </a:prstGeom>
+          <a:noFill/>
+        </p:spPr>
+        <p:txBody>
+          <a:bodyPr wrap="square" anchor="t" lIns="0" rIns="0" tIns="0" bIns="0">
+            <a:spAutoFit/>
+          </a:bodyPr>
+          <a:lstStyle/>
+          <a:p>
+            <a:pPr algn="l"/>
+            <a:r>
+              <a:rPr sz="1600" b="0">
+                <a:solidFill>
+                  <a:srgbClr val="062D3F"/>
+                </a:solidFill>
+                <a:latin typeface="Circe"/>
+              </a:rPr>
+              <a:t>ВГП на душу населения</a:t>
+            </a:r>
+          </a:p>
+          <a:p>
+            <a:pPr algn="l"/>
+            <a:r>
+              <a:rPr sz="1600" b="0">
+                <a:solidFill>
+                  <a:srgbClr val="2F5D75"/>
+                </a:solidFill>
+                <a:latin typeface="Circe"/>
+              </a:rPr>
+              <a:t>РФ – 824 тыс. руб.</a:t>
+            </a:r>
+          </a:p>
+        </p:txBody>
+      </p:sp>
+      <p:sp>
+        <p:nvSpPr>
+          <p:cNvPr id="563" name="Условный знак"/>
+          <p:cNvSpPr/>
+          <p:nvPr/>
+        </p:nvSpPr>
+        <p:spPr>
+          <a:xfrm>
+            <a:off x="14401800" y="8778240"/>
+            <a:ext cx="256032" cy="201168"/>
+          </a:xfrm>
+          <a:prstGeom prst="rect">
+            <a:avLst/>
+          </a:prstGeom>
+          <a:solidFill>
+            <a:srgbClr val="FFCC00"/>
+          </a:solidFill>
+          <a:ln>
+            <a:noFill/>
+          </a:ln>
+        </p:spPr>
+        <p:txBody>
+          <a:bodyPr rtlCol="0" anchor="ctr"/>
+          <a:lstStyle/>
+          <a:p>
+            <a:pPr algn="ctr"/>
+          </a:p>
+        </p:txBody>
+      </p:sp>
+      <p:sp>
+        <p:nvSpPr>
+          <p:cNvPr id="564" name="Легенда"/>
           <p:cNvSpPr txBox="1"/>
           <p:nvPr/>
         </p:nvSpPr>
@@ -14348,7 +14545,7 @@
       </p:sp>
       <p:sp>
         <p:nvSpPr>
-          <p:cNvPr id="558" name="Условный знак"/>
+          <p:cNvPr id="565" name="Условный знак"/>
           <p:cNvSpPr/>
           <p:nvPr/>
         </p:nvSpPr>
@@ -14377,7 +14574,7 @@
       </p:sp>
       <p:sp>
         <p:nvSpPr>
-          <p:cNvPr id="559" name="Легенда"/>
+          <p:cNvPr id="566" name="Легенда"/>
           <p:cNvSpPr txBox="1"/>
           <p:nvPr/>
         </p:nvSpPr>

</xml_diff>